<commit_message>
docs: update slides with deployment testing findings and results
</commit_message>
<xml_diff>
--- a/slides/報告_柏融.pptx
+++ b/slides/報告_柏融.pptx
@@ -6084,7 +6084,7 @@
                   <a:srgbClr val="FFFFFF"/>
                 </a:solidFill>
               </a:rPr>
-              <a:t>自驗 20 題：成功經驗與地雷</a:t>
+              <a:t>自驗 20 題：成功、地雷與部署測試</a:t>
             </a:r>
           </a:p>
         </p:txBody>
@@ -6118,7 +6118,7 @@
                   <a:srgbClr val="AACCDD"/>
                 </a:solidFill>
               </a:rPr>
-              <a:t>4 資料 × 5 題，全部驗證通過</a:t>
+              <a:t>前處理 + Railway 部署 + 向量搜尋調優</a:t>
             </a:r>
           </a:p>
         </p:txBody>
@@ -6175,7 +6175,7 @@
         <p:spPr>
           <a:xfrm>
             <a:off x="365760" y="1600200"/>
-            <a:ext cx="5486400" cy="365760"/>
+            <a:ext cx="5303520" cy="320040"/>
           </a:xfrm>
           <a:prstGeom prst="rect">
             <a:avLst/>
@@ -6190,12 +6190,12 @@
           <a:p>
             <a:pPr algn="l"/>
             <a:r>
-              <a:rPr sz="1500" b="1">
+              <a:rPr sz="1300" b="1">
                 <a:solidFill>
                   <a:srgbClr val="27AE60"/>
                 </a:solidFill>
               </a:rPr>
-              <a:t>✅ 成功範例（4 題代表）</a:t>
+              <a:t>✅ 成功範例</a:t>
             </a:r>
           </a:p>
         </p:txBody>
@@ -6209,8 +6209,8 @@
           <p:nvPr/>
         </p:nvGraphicFramePr>
         <p:xfrm>
-          <a:off x="365760" y="1965960"/>
-          <a:ext cx="5486400" cy="2011680"/>
+          <a:off x="365760" y="1938528"/>
+          <a:ext cx="5303520" cy="1737360"/>
         </p:xfrm>
         <a:graphic>
           <a:graphicData uri="http://schemas.openxmlformats.org/drawingml/2006/table">
@@ -6219,11 +6219,11 @@
                 <a:tableStyleId>{5C22544A-7EE6-4342-B048-85BDC9FD1C3A}</a:tableStyleId>
               </a:tblPr>
               <a:tblGrid>
-                <a:gridCol w="1828800"/>
-                <a:gridCol w="1828800"/>
-                <a:gridCol w="1828800"/>
+                <a:gridCol w="1767840"/>
+                <a:gridCol w="1767840"/>
+                <a:gridCol w="1767840"/>
               </a:tblGrid>
-              <a:tr h="402336">
+              <a:tr h="347472">
                 <a:tc>
                   <a:txBody>
                     <a:bodyPr wrap="square"/>
@@ -6291,7 +6291,7 @@
                   </a:tcPr>
                 </a:tc>
               </a:tr>
-              <a:tr h="402336">
+              <a:tr h="347472">
                 <a:tc>
                   <a:txBody>
                     <a:bodyPr wrap="square"/>
@@ -6348,7 +6348,7 @@
                             <a:srgbClr val="444444"/>
                           </a:solidFill>
                         </a:rPr>
-                        <a:t>分4筆ATM提領12萬元整</a:t>
+                        <a:t>ATM 分4筆提領12萬</a:t>
                       </a:r>
                     </a:p>
                   </a:txBody>
@@ -6359,7 +6359,7 @@
                   </a:tcPr>
                 </a:tc>
               </a:tr>
-              <a:tr h="402336">
+              <a:tr h="347472">
                 <a:tc>
                   <a:txBody>
                     <a:bodyPr wrap="square"/>
@@ -6394,7 +6394,7 @@
                             <a:srgbClr val="444444"/>
                           </a:solidFill>
                         </a:rPr>
-                        <a:t>新北市總人口多少？</a:t>
+                        <a:t>新北市總人口？</a:t>
                       </a:r>
                     </a:p>
                   </a:txBody>
@@ -6427,7 +6427,7 @@
                   </a:tcPr>
                 </a:tc>
               </a:tr>
-              <a:tr h="402336">
+              <a:tr h="347472">
                 <a:tc>
                   <a:txBody>
                     <a:bodyPr wrap="square"/>
@@ -6495,7 +6495,7 @@
                   </a:tcPr>
                 </a:tc>
               </a:tr>
-              <a:tr h="402336">
+              <a:tr h="347472">
                 <a:tc>
                   <a:txBody>
                     <a:bodyPr wrap="square"/>
@@ -6575,8 +6575,8 @@
         </p:nvSpPr>
         <p:spPr>
           <a:xfrm>
-            <a:off x="6217920" y="1600200"/>
-            <a:ext cx="5577840" cy="365760"/>
+            <a:off x="6035040" y="1600200"/>
+            <a:ext cx="5760720" cy="320040"/>
           </a:xfrm>
           <a:prstGeom prst="rect">
             <a:avLst/>
@@ -6591,12 +6591,12 @@
           <a:p>
             <a:pPr algn="l"/>
             <a:r>
-              <a:rPr sz="1500" b="1">
+              <a:rPr sz="1300" b="1">
                 <a:solidFill>
                   <a:srgbClr val="E86A1A"/>
                 </a:solidFill>
               </a:rPr>
-              <a:t>⚠️ 踩到的地雷</a:t>
+              <a:t>⚠️ 前處理地雷</a:t>
             </a:r>
           </a:p>
         </p:txBody>
@@ -6610,8 +6610,8 @@
           <p:nvPr/>
         </p:nvGraphicFramePr>
         <p:xfrm>
-          <a:off x="6217920" y="1965960"/>
-          <a:ext cx="5577840" cy="2377440"/>
+          <a:off x="6035040" y="1938528"/>
+          <a:ext cx="5760720" cy="1737360"/>
         </p:xfrm>
         <a:graphic>
           <a:graphicData uri="http://schemas.openxmlformats.org/drawingml/2006/table">
@@ -6620,11 +6620,11 @@
                 <a:tableStyleId>{5C22544A-7EE6-4342-B048-85BDC9FD1C3A}</a:tableStyleId>
               </a:tblPr>
               <a:tblGrid>
-                <a:gridCol w="1859280"/>
-                <a:gridCol w="1859280"/>
-                <a:gridCol w="1859280"/>
+                <a:gridCol w="1920240"/>
+                <a:gridCol w="1920240"/>
+                <a:gridCol w="1920240"/>
               </a:tblGrid>
-              <a:tr h="396240">
+              <a:tr h="347472">
                 <a:tc>
                   <a:txBody>
                     <a:bodyPr wrap="square"/>
@@ -6692,7 +6692,7 @@
                   </a:tcPr>
                 </a:tc>
               </a:tr>
-              <a:tr h="396240">
+              <a:tr h="347472">
                 <a:tc>
                   <a:txBody>
                     <a:bodyPr wrap="square"/>
@@ -6749,7 +6749,7 @@
                             <a:srgbClr val="444444"/>
                           </a:solidFill>
                         </a:rPr>
-                        <a:t>加 OCR（Tesseract）</a:t>
+                        <a:t>Tesseract OCR</a:t>
                       </a:r>
                     </a:p>
                   </a:txBody>
@@ -6760,7 +6760,7 @@
                   </a:tcPr>
                 </a:tc>
               </a:tr>
-              <a:tr h="396240">
+              <a:tr h="347472">
                 <a:tc>
                   <a:txBody>
                     <a:bodyPr wrap="square"/>
@@ -6795,7 +6795,7 @@
                             <a:srgbClr val="444444"/>
                           </a:solidFill>
                         </a:rPr>
-                        <a:t>合併儲存格導致 Unnamed</a:t>
+                        <a:t>合併儲存格→Unnamed</a:t>
                       </a:r>
                     </a:p>
                   </a:txBody>
@@ -6817,7 +6817,7 @@
                             <a:srgbClr val="444444"/>
                           </a:solidFill>
                         </a:rPr>
-                        <a:t>改用 xlrd 逐格</a:t>
+                        <a:t>xlrd 逐格讀取</a:t>
                       </a:r>
                     </a:p>
                   </a:txBody>
@@ -6828,7 +6828,7 @@
                   </a:tcPr>
                 </a:tc>
               </a:tr>
-              <a:tr h="396240">
+              <a:tr h="347472">
                 <a:tc>
                   <a:txBody>
                     <a:bodyPr wrap="square"/>
@@ -6885,7 +6885,7 @@
                             <a:srgbClr val="444444"/>
                           </a:solidFill>
                         </a:rPr>
-                        <a:t>換 soundfile 讀取</a:t>
+                        <a:t>換 soundfile</a:t>
                       </a:r>
                     </a:p>
                   </a:txBody>
@@ -6896,7 +6896,7 @@
                   </a:tcPr>
                 </a:tc>
               </a:tr>
-              <a:tr h="396240">
+              <a:tr h="347472">
                 <a:tc>
                   <a:txBody>
                     <a:bodyPr wrap="square"/>
@@ -6953,7 +6953,7 @@
                             <a:srgbClr val="444444"/>
                           </a:solidFill>
                         </a:rPr>
-                        <a:t>改本地執行 Whisper</a:t>
+                        <a:t>本地執行 Whisper</a:t>
                       </a:r>
                     </a:p>
                   </a:txBody>
@@ -6964,7 +6964,136 @@
                   </a:tcPr>
                 </a:tc>
               </a:tr>
-              <a:tr h="396240">
+            </a:tbl>
+          </a:graphicData>
+        </a:graphic>
+      </p:graphicFrame>
+      <p:sp>
+        <p:nvSpPr>
+          <p:cNvPr id="10" name="TextBox 9"/>
+          <p:cNvSpPr txBox="1"/>
+          <p:nvPr/>
+        </p:nvSpPr>
+        <p:spPr>
+          <a:xfrm>
+            <a:off x="365760" y="3794760"/>
+            <a:ext cx="11430000" cy="320040"/>
+          </a:xfrm>
+          <a:prstGeom prst="rect">
+            <a:avLst/>
+          </a:prstGeom>
+          <a:noFill/>
+        </p:spPr>
+        <p:txBody>
+          <a:bodyPr wrap="square">
+            <a:spAutoFit/>
+          </a:bodyPr>
+          <a:lstStyle/>
+          <a:p>
+            <a:pPr algn="l"/>
+            <a:r>
+              <a:rPr sz="1300" b="1">
+                <a:solidFill>
+                  <a:srgbClr val="6A1A8A"/>
+                </a:solidFill>
+              </a:rPr>
+              <a:t>🚀 部署測試（Railway）發現的問題</a:t>
+            </a:r>
+          </a:p>
+        </p:txBody>
+      </p:sp>
+      <p:graphicFrame>
+        <p:nvGraphicFramePr>
+          <p:cNvPr id="11" name="Table 10"/>
+          <p:cNvGraphicFramePr>
+            <a:graphicFrameLocks noGrp="1"/>
+          </p:cNvGraphicFramePr>
+          <p:nvPr/>
+        </p:nvGraphicFramePr>
+        <p:xfrm>
+          <a:off x="365760" y="4133087"/>
+          <a:ext cx="11430000" cy="2423160"/>
+        </p:xfrm>
+        <a:graphic>
+          <a:graphicData uri="http://schemas.openxmlformats.org/drawingml/2006/table">
+            <a:tbl>
+              <a:tblPr firstRow="1" bandRow="1">
+                <a:tableStyleId>{5C22544A-7EE6-4342-B048-85BDC9FD1C3A}</a:tableStyleId>
+              </a:tblPr>
+              <a:tblGrid>
+                <a:gridCol w="3810000"/>
+                <a:gridCol w="3810000"/>
+                <a:gridCol w="3810000"/>
+              </a:tblGrid>
+              <a:tr h="346165">
+                <a:tc>
+                  <a:txBody>
+                    <a:bodyPr wrap="square"/>
+                    <a:lstStyle/>
+                    <a:p>
+                      <a:pPr algn="ctr"/>
+                      <a:r>
+                        <a:rPr sz="1400" b="1">
+                          <a:solidFill>
+                            <a:srgbClr val="FFFFFF"/>
+                          </a:solidFill>
+                        </a:rPr>
+                        <a:t>問題</a:t>
+                      </a:r>
+                    </a:p>
+                  </a:txBody>
+                  <a:tcPr>
+                    <a:solidFill>
+                      <a:srgbClr val="6A1A8A"/>
+                    </a:solidFill>
+                  </a:tcPr>
+                </a:tc>
+                <a:tc>
+                  <a:txBody>
+                    <a:bodyPr wrap="square"/>
+                    <a:lstStyle/>
+                    <a:p>
+                      <a:pPr algn="ctr"/>
+                      <a:r>
+                        <a:rPr sz="1400" b="1">
+                          <a:solidFill>
+                            <a:srgbClr val="FFFFFF"/>
+                          </a:solidFill>
+                        </a:rPr>
+                        <a:t>根本原因</a:t>
+                      </a:r>
+                    </a:p>
+                  </a:txBody>
+                  <a:tcPr>
+                    <a:solidFill>
+                      <a:srgbClr val="6A1A8A"/>
+                    </a:solidFill>
+                  </a:tcPr>
+                </a:tc>
+                <a:tc>
+                  <a:txBody>
+                    <a:bodyPr wrap="square"/>
+                    <a:lstStyle/>
+                    <a:p>
+                      <a:pPr algn="ctr"/>
+                      <a:r>
+                        <a:rPr sz="1400" b="1">
+                          <a:solidFill>
+                            <a:srgbClr val="FFFFFF"/>
+                          </a:solidFill>
+                        </a:rPr>
+                        <a:t>解法</a:t>
+                      </a:r>
+                    </a:p>
+                  </a:txBody>
+                  <a:tcPr>
+                    <a:solidFill>
+                      <a:srgbClr val="6A1A8A"/>
+                    </a:solidFill>
+                  </a:tcPr>
+                </a:tc>
+              </a:tr>
+              <a:tr h="346165">
                 <a:tc>
                   <a:txBody>
                     <a:bodyPr wrap="square"/>
@@ -6977,7 +7106,7 @@
                             <a:srgbClr val="444444"/>
                           </a:solidFill>
                         </a:rPr>
-                        <a:t>Prompt 超長</a:t>
+                        <a:t>Build 失敗：無法偵測語言</a:t>
                       </a:r>
                     </a:p>
                   </a:txBody>
@@ -6999,7 +7128,7 @@
                             <a:srgbClr val="444444"/>
                           </a:solidFill>
                         </a:rPr>
-                        <a:t>100份公文一次全塞</a:t>
+                        <a:t>根目錄無 requirements.txt</a:t>
                       </a:r>
                     </a:p>
                   </a:txBody>
@@ -7021,7 +7150,7 @@
                             <a:srgbClr val="444444"/>
                           </a:solidFill>
                         </a:rPr>
-                        <a:t>動態選相關 references</a:t>
+                        <a:t>根目錄加 requirements.txt</a:t>
                       </a:r>
                     </a:p>
                   </a:txBody>
@@ -7032,155 +7161,350 @@
                   </a:tcPr>
                 </a:tc>
               </a:tr>
+              <a:tr h="346165">
+                <a:tc>
+                  <a:txBody>
+                    <a:bodyPr wrap="square"/>
+                    <a:lstStyle/>
+                    <a:p>
+                      <a:pPr algn="l"/>
+                      <a:r>
+                        <a:rPr sz="1300" b="0">
+                          <a:solidFill>
+                            <a:srgbClr val="444444"/>
+                          </a:solidFill>
+                        </a:rPr>
+                        <a:t>Build 失敗：無 start cmd</a:t>
+                      </a:r>
+                    </a:p>
+                  </a:txBody>
+                  <a:tcPr>
+                    <a:solidFill>
+                      <a:srgbClr val="FFFFFF"/>
+                    </a:solidFill>
+                  </a:tcPr>
+                </a:tc>
+                <a:tc>
+                  <a:txBody>
+                    <a:bodyPr wrap="square"/>
+                    <a:lstStyle/>
+                    <a:p>
+                      <a:pPr algn="l"/>
+                      <a:r>
+                        <a:rPr sz="1300" b="0">
+                          <a:solidFill>
+                            <a:srgbClr val="444444"/>
+                          </a:solidFill>
+                        </a:rPr>
+                        <a:t>main.py 不在根目錄</a:t>
+                      </a:r>
+                    </a:p>
+                  </a:txBody>
+                  <a:tcPr>
+                    <a:solidFill>
+                      <a:srgbClr val="FFFFFF"/>
+                    </a:solidFill>
+                  </a:tcPr>
+                </a:tc>
+                <a:tc>
+                  <a:txBody>
+                    <a:bodyPr wrap="square"/>
+                    <a:lstStyle/>
+                    <a:p>
+                      <a:pPr algn="l"/>
+                      <a:r>
+                        <a:rPr sz="1300" b="0">
+                          <a:solidFill>
+                            <a:srgbClr val="444444"/>
+                          </a:solidFill>
+                        </a:rPr>
+                        <a:t>根目錄加 main.py 引入 app</a:t>
+                      </a:r>
+                    </a:p>
+                  </a:txBody>
+                  <a:tcPr>
+                    <a:solidFill>
+                      <a:srgbClr val="FFFFFF"/>
+                    </a:solidFill>
+                  </a:tcPr>
+                </a:tc>
+              </a:tr>
+              <a:tr h="346165">
+                <a:tc>
+                  <a:txBody>
+                    <a:bodyPr wrap="square"/>
+                    <a:lstStyle/>
+                    <a:p>
+                      <a:pPr algn="l"/>
+                      <a:r>
+                        <a:rPr sz="1300" b="0">
+                          <a:solidFill>
+                            <a:srgbClr val="444444"/>
+                          </a:solidFill>
+                        </a:rPr>
+                        <a:t>向量搜尋未啟用（fulltext）</a:t>
+                      </a:r>
+                    </a:p>
+                  </a:txBody>
+                  <a:tcPr>
+                    <a:solidFill>
+                      <a:srgbClr val="F4F6F8"/>
+                    </a:solidFill>
+                  </a:tcPr>
+                </a:tc>
+                <a:tc>
+                  <a:txBody>
+                    <a:bodyPr wrap="square"/>
+                    <a:lstStyle/>
+                    <a:p>
+                      <a:pPr algn="l"/>
+                      <a:r>
+                        <a:rPr sz="1300" b="0">
+                          <a:solidFill>
+                            <a:srgbClr val="444444"/>
+                          </a:solidFill>
+                        </a:rPr>
+                        <a:t>chromadb 未列入 requirements</a:t>
+                      </a:r>
+                    </a:p>
+                  </a:txBody>
+                  <a:tcPr>
+                    <a:solidFill>
+                      <a:srgbClr val="F4F6F8"/>
+                    </a:solidFill>
+                  </a:tcPr>
+                </a:tc>
+                <a:tc>
+                  <a:txBody>
+                    <a:bodyPr wrap="square"/>
+                    <a:lstStyle/>
+                    <a:p>
+                      <a:pPr algn="l"/>
+                      <a:r>
+                        <a:rPr sz="1300" b="0">
+                          <a:solidFill>
+                            <a:srgbClr val="444444"/>
+                          </a:solidFill>
+                        </a:rPr>
+                        <a:t>補加 chromadb==1.5.9</a:t>
+                      </a:r>
+                    </a:p>
+                  </a:txBody>
+                  <a:tcPr>
+                    <a:solidFill>
+                      <a:srgbClr val="F4F6F8"/>
+                    </a:solidFill>
+                  </a:tcPr>
+                </a:tc>
+              </a:tr>
+              <a:tr h="346165">
+                <a:tc>
+                  <a:txBody>
+                    <a:bodyPr wrap="square"/>
+                    <a:lstStyle/>
+                    <a:p>
+                      <a:pPr algn="l"/>
+                      <a:r>
+                        <a:rPr sz="1300" b="0">
+                          <a:solidFill>
+                            <a:srgbClr val="444444"/>
+                          </a:solidFill>
+                        </a:rPr>
+                        <a:t>ZIP 找不到特定公文編號</a:t>
+                      </a:r>
+                    </a:p>
+                  </a:txBody>
+                  <a:tcPr>
+                    <a:solidFill>
+                      <a:srgbClr val="FFFFFF"/>
+                    </a:solidFill>
+                  </a:tcPr>
+                </a:tc>
+                <a:tc>
+                  <a:txBody>
+                    <a:bodyPr wrap="square"/>
+                    <a:lstStyle/>
+                    <a:p>
+                      <a:pPr algn="l"/>
+                      <a:r>
+                        <a:rPr sz="1300" b="0">
+                          <a:solidFill>
+                            <a:srgbClr val="444444"/>
+                          </a:solidFill>
+                        </a:rPr>
+                        <a:t>TOP_K=5 + 100份文件相似度接近</a:t>
+                      </a:r>
+                    </a:p>
+                  </a:txBody>
+                  <a:tcPr>
+                    <a:solidFill>
+                      <a:srgbClr val="FFFFFF"/>
+                    </a:solidFill>
+                  </a:tcPr>
+                </a:tc>
+                <a:tc>
+                  <a:txBody>
+                    <a:bodyPr wrap="square"/>
+                    <a:lstStyle/>
+                    <a:p>
+                      <a:pPr algn="l"/>
+                      <a:r>
+                        <a:rPr sz="1300" b="0">
+                          <a:solidFill>
+                            <a:srgbClr val="444444"/>
+                          </a:solidFill>
+                        </a:rPr>
+                        <a:t>ZIP TOP_K: 5 → 15</a:t>
+                      </a:r>
+                    </a:p>
+                  </a:txBody>
+                  <a:tcPr>
+                    <a:solidFill>
+                      <a:srgbClr val="FFFFFF"/>
+                    </a:solidFill>
+                  </a:tcPr>
+                </a:tc>
+              </a:tr>
+              <a:tr h="346165">
+                <a:tc>
+                  <a:txBody>
+                    <a:bodyPr wrap="square"/>
+                    <a:lstStyle/>
+                    <a:p>
+                      <a:pPr algn="l"/>
+                      <a:r>
+                        <a:rPr sz="1300" b="0">
+                          <a:solidFill>
+                            <a:srgbClr val="444444"/>
+                          </a:solidFill>
+                        </a:rPr>
+                        <a:t>429 Too Many Requests</a:t>
+                      </a:r>
+                    </a:p>
+                  </a:txBody>
+                  <a:tcPr>
+                    <a:solidFill>
+                      <a:srgbClr val="F4F6F8"/>
+                    </a:solidFill>
+                  </a:tcPr>
+                </a:tc>
+                <a:tc>
+                  <a:txBody>
+                    <a:bodyPr wrap="square"/>
+                    <a:lstStyle/>
+                    <a:p>
+                      <a:pPr algn="l"/>
+                      <a:r>
+                        <a:rPr sz="1300" b="0">
+                          <a:solidFill>
+                            <a:srgbClr val="444444"/>
+                          </a:solidFill>
+                        </a:rPr>
+                        <a:t>連續請求觸發 NCHC 流量限制</a:t>
+                      </a:r>
+                    </a:p>
+                  </a:txBody>
+                  <a:tcPr>
+                    <a:solidFill>
+                      <a:srgbClr val="F4F6F8"/>
+                    </a:solidFill>
+                  </a:tcPr>
+                </a:tc>
+                <a:tc>
+                  <a:txBody>
+                    <a:bodyPr wrap="square"/>
+                    <a:lstStyle/>
+                    <a:p>
+                      <a:pPr algn="l"/>
+                      <a:r>
+                        <a:rPr sz="1300" b="0">
+                          <a:solidFill>
+                            <a:srgbClr val="444444"/>
+                          </a:solidFill>
+                        </a:rPr>
+                        <a:t>Retry + backoff（10/20/40s）</a:t>
+                      </a:r>
+                    </a:p>
+                  </a:txBody>
+                  <a:tcPr>
+                    <a:solidFill>
+                      <a:srgbClr val="F4F6F8"/>
+                    </a:solidFill>
+                  </a:tcPr>
+                </a:tc>
+              </a:tr>
+              <a:tr h="346170">
+                <a:tc>
+                  <a:txBody>
+                    <a:bodyPr wrap="square"/>
+                    <a:lstStyle/>
+                    <a:p>
+                      <a:pPr algn="l"/>
+                      <a:r>
+                        <a:rPr sz="1300" b="0">
+                          <a:solidFill>
+                            <a:srgbClr val="444444"/>
+                          </a:solidFill>
+                        </a:rPr>
+                        <a:t>中文答題準確率偏低</a:t>
+                      </a:r>
+                    </a:p>
+                  </a:txBody>
+                  <a:tcPr>
+                    <a:solidFill>
+                      <a:srgbClr val="FFFFFF"/>
+                    </a:solidFill>
+                  </a:tcPr>
+                </a:tc>
+                <a:tc>
+                  <a:txBody>
+                    <a:bodyPr wrap="square"/>
+                    <a:lstStyle/>
+                    <a:p>
+                      <a:pPr algn="l"/>
+                      <a:r>
+                        <a:rPr sz="1300" b="0">
+                          <a:solidFill>
+                            <a:srgbClr val="444444"/>
+                          </a:solidFill>
+                        </a:rPr>
+                        <a:t>英文 embedding 模型</a:t>
+                      </a:r>
+                    </a:p>
+                  </a:txBody>
+                  <a:tcPr>
+                    <a:solidFill>
+                      <a:srgbClr val="FFFFFF"/>
+                    </a:solidFill>
+                  </a:tcPr>
+                </a:tc>
+                <a:tc>
+                  <a:txBody>
+                    <a:bodyPr wrap="square"/>
+                    <a:lstStyle/>
+                    <a:p>
+                      <a:pPr algn="l"/>
+                      <a:r>
+                        <a:rPr sz="1300" b="0">
+                          <a:solidFill>
+                            <a:srgbClr val="444444"/>
+                          </a:solidFill>
+                        </a:rPr>
+                        <a:t>換多語言 MiniLM-L12-v2</a:t>
+                      </a:r>
+                    </a:p>
+                  </a:txBody>
+                  <a:tcPr>
+                    <a:solidFill>
+                      <a:srgbClr val="FFFFFF"/>
+                    </a:solidFill>
+                  </a:tcPr>
+                </a:tc>
+              </a:tr>
             </a:tbl>
           </a:graphicData>
         </a:graphic>
       </p:graphicFrame>
-      <p:sp>
-        <p:nvSpPr>
-          <p:cNvPr id="10" name="Rectangle 9"/>
-          <p:cNvSpPr/>
-          <p:nvPr/>
-        </p:nvSpPr>
-        <p:spPr>
-          <a:xfrm>
-            <a:off x="365760" y="4160520"/>
-            <a:ext cx="11430000" cy="320040"/>
-          </a:xfrm>
-          <a:prstGeom prst="rect">
-            <a:avLst/>
-          </a:prstGeom>
-          <a:solidFill>
-            <a:srgbClr val="008787"/>
-          </a:solidFill>
-          <a:ln>
-            <a:noFill/>
-          </a:ln>
-        </p:spPr>
-        <p:style>
-          <a:lnRef idx="1">
-            <a:schemeClr val="accent1"/>
-          </a:lnRef>
-          <a:fillRef idx="3">
-            <a:schemeClr val="accent1"/>
-          </a:fillRef>
-          <a:effectRef idx="2">
-            <a:schemeClr val="accent1"/>
-          </a:effectRef>
-          <a:fontRef idx="minor">
-            <a:schemeClr val="lt1"/>
-          </a:fontRef>
-        </p:style>
-        <p:txBody>
-          <a:bodyPr rtlCol="0" anchor="ctr"/>
-          <a:lstStyle/>
-          <a:p>
-            <a:pPr algn="ctr"/>
-          </a:p>
-        </p:txBody>
-      </p:sp>
-      <p:sp>
-        <p:nvSpPr>
-          <p:cNvPr id="11" name="TextBox 10"/>
-          <p:cNvSpPr txBox="1"/>
-          <p:nvPr/>
-        </p:nvSpPr>
-        <p:spPr>
-          <a:xfrm>
-            <a:off x="457200" y="4178808"/>
-            <a:ext cx="2743200" cy="274320"/>
-          </a:xfrm>
-          <a:prstGeom prst="rect">
-            <a:avLst/>
-          </a:prstGeom>
-          <a:noFill/>
-        </p:spPr>
-        <p:txBody>
-          <a:bodyPr wrap="square">
-            <a:spAutoFit/>
-          </a:bodyPr>
-          <a:lstStyle/>
-          <a:p>
-            <a:pPr algn="l"/>
-            <a:r>
-              <a:rPr sz="1300" b="1">
-                <a:solidFill>
-                  <a:srgbClr val="FFFFFF"/>
-                </a:solidFill>
-              </a:rPr>
-              <a:t>問答架構</a:t>
-            </a:r>
-          </a:p>
-        </p:txBody>
-      </p:sp>
-      <p:sp>
-        <p:nvSpPr>
-          <p:cNvPr id="12" name="TextBox 11"/>
-          <p:cNvSpPr txBox="1"/>
-          <p:nvPr/>
-        </p:nvSpPr>
-        <p:spPr>
-          <a:xfrm>
-            <a:off x="365760" y="4572000"/>
-            <a:ext cx="11430000" cy="457200"/>
-          </a:xfrm>
-          <a:prstGeom prst="rect">
-            <a:avLst/>
-          </a:prstGeom>
-          <a:noFill/>
-        </p:spPr>
-        <p:txBody>
-          <a:bodyPr wrap="square">
-            <a:spAutoFit/>
-          </a:bodyPr>
-          <a:lstStyle/>
-          <a:p>
-            <a:pPr algn="ctr"/>
-            <a:r>
-              <a:rPr sz="1400" b="0">
-                <a:solidFill>
-                  <a:srgbClr val="1A2E4A"/>
-                </a:solidFill>
-              </a:rPr>
-              <a:t>問題  →  Hermes 載入 references/  →  組 System Prompt + 問題  →  NCHC Gemma 4 31B  →  引用來源 + 答案</a:t>
-            </a:r>
-          </a:p>
-        </p:txBody>
-      </p:sp>
-      <p:sp>
-        <p:nvSpPr>
-          <p:cNvPr id="13" name="TextBox 12"/>
-          <p:cNvSpPr txBox="1"/>
-          <p:nvPr/>
-        </p:nvSpPr>
-        <p:spPr>
-          <a:xfrm>
-            <a:off x="365760" y="5074920"/>
-            <a:ext cx="11430000" cy="365760"/>
-          </a:xfrm>
-          <a:prstGeom prst="rect">
-            <a:avLst/>
-          </a:prstGeom>
-          <a:noFill/>
-        </p:spPr>
-        <p:txBody>
-          <a:bodyPr wrap="square">
-            <a:spAutoFit/>
-          </a:bodyPr>
-          <a:lstStyle/>
-          <a:p>
-            <a:pPr algn="ctr"/>
-            <a:r>
-              <a:rPr sz="1300" b="0">
-                <a:solidFill>
-                  <a:srgbClr val="666666"/>
-                </a:solidFill>
-              </a:rPr>
-              <a:t>規則：只能根據 references/ 回答，找不到就說「資料中未提及」，並引用來源段落</a:t>
-            </a:r>
-          </a:p>
-        </p:txBody>
-      </p:sp>
     </p:spTree>
   </p:cSld>
   <p:clrMapOvr>
@@ -7305,7 +7629,7 @@
                   <a:srgbClr val="AACCDD"/>
                 </a:solidFill>
               </a:rPr>
-              <a:t>總製作時間約 4 小時</a:t>
+              <a:t>總製作時間約 6 小時（含部署測試）</a:t>
             </a:r>
           </a:p>
         </p:txBody>
@@ -8062,6 +8386,228 @@
         <p:spPr>
           <a:xfrm>
             <a:off x="365760" y="5742432"/>
+            <a:ext cx="201168" cy="411480"/>
+          </a:xfrm>
+          <a:prstGeom prst="rect">
+            <a:avLst/>
+          </a:prstGeom>
+          <a:solidFill>
+            <a:srgbClr val="008787"/>
+          </a:solidFill>
+          <a:ln>
+            <a:noFill/>
+          </a:ln>
+        </p:spPr>
+        <p:style>
+          <a:lnRef idx="1">
+            <a:schemeClr val="accent1"/>
+          </a:lnRef>
+          <a:fillRef idx="3">
+            <a:schemeClr val="accent1"/>
+          </a:fillRef>
+          <a:effectRef idx="2">
+            <a:schemeClr val="accent1"/>
+          </a:effectRef>
+          <a:fontRef idx="minor">
+            <a:schemeClr val="lt1"/>
+          </a:fontRef>
+        </p:style>
+        <p:txBody>
+          <a:bodyPr rtlCol="0" anchor="ctr"/>
+          <a:lstStyle/>
+          <a:p>
+            <a:pPr algn="ctr"/>
+          </a:p>
+        </p:txBody>
+      </p:sp>
+      <p:sp>
+        <p:nvSpPr>
+          <p:cNvPr id="26" name="TextBox 25"/>
+          <p:cNvSpPr txBox="1"/>
+          <p:nvPr/>
+        </p:nvSpPr>
+        <p:spPr>
+          <a:xfrm>
+            <a:off x="685800" y="5779008"/>
+            <a:ext cx="3291840" cy="411480"/>
+          </a:xfrm>
+          <a:prstGeom prst="rect">
+            <a:avLst/>
+          </a:prstGeom>
+          <a:noFill/>
+        </p:spPr>
+        <p:txBody>
+          <a:bodyPr wrap="square">
+            <a:spAutoFit/>
+          </a:bodyPr>
+          <a:lstStyle/>
+          <a:p>
+            <a:pPr algn="l"/>
+            <a:r>
+              <a:rPr sz="1400" b="0">
+                <a:solidFill>
+                  <a:srgbClr val="444444"/>
+                </a:solidFill>
+              </a:rPr>
+              <a:t>向量搜尋實作（ChromaDB）</a:t>
+            </a:r>
+          </a:p>
+        </p:txBody>
+      </p:sp>
+      <p:sp>
+        <p:nvSpPr>
+          <p:cNvPr id="27" name="TextBox 26"/>
+          <p:cNvSpPr txBox="1"/>
+          <p:nvPr/>
+        </p:nvSpPr>
+        <p:spPr>
+          <a:xfrm>
+            <a:off x="4023360" y="5779008"/>
+            <a:ext cx="1280160" cy="411480"/>
+          </a:xfrm>
+          <a:prstGeom prst="rect">
+            <a:avLst/>
+          </a:prstGeom>
+          <a:noFill/>
+        </p:spPr>
+        <p:txBody>
+          <a:bodyPr wrap="square">
+            <a:spAutoFit/>
+          </a:bodyPr>
+          <a:lstStyle/>
+          <a:p>
+            <a:pPr algn="r"/>
+            <a:r>
+              <a:rPr sz="1400" b="1">
+                <a:solidFill>
+                  <a:srgbClr val="008787"/>
+                </a:solidFill>
+              </a:rPr>
+              <a:t>~1 hr</a:t>
+            </a:r>
+          </a:p>
+        </p:txBody>
+      </p:sp>
+      <p:sp>
+        <p:nvSpPr>
+          <p:cNvPr id="28" name="Rectangle 27"/>
+          <p:cNvSpPr/>
+          <p:nvPr/>
+        </p:nvSpPr>
+        <p:spPr>
+          <a:xfrm>
+            <a:off x="365760" y="6364224"/>
+            <a:ext cx="201168" cy="411480"/>
+          </a:xfrm>
+          <a:prstGeom prst="rect">
+            <a:avLst/>
+          </a:prstGeom>
+          <a:solidFill>
+            <a:srgbClr val="E86A1A"/>
+          </a:solidFill>
+          <a:ln>
+            <a:noFill/>
+          </a:ln>
+        </p:spPr>
+        <p:style>
+          <a:lnRef idx="1">
+            <a:schemeClr val="accent1"/>
+          </a:lnRef>
+          <a:fillRef idx="3">
+            <a:schemeClr val="accent1"/>
+          </a:fillRef>
+          <a:effectRef idx="2">
+            <a:schemeClr val="accent1"/>
+          </a:effectRef>
+          <a:fontRef idx="minor">
+            <a:schemeClr val="lt1"/>
+          </a:fontRef>
+        </p:style>
+        <p:txBody>
+          <a:bodyPr rtlCol="0" anchor="ctr"/>
+          <a:lstStyle/>
+          <a:p>
+            <a:pPr algn="ctr"/>
+          </a:p>
+        </p:txBody>
+      </p:sp>
+      <p:sp>
+        <p:nvSpPr>
+          <p:cNvPr id="29" name="TextBox 28"/>
+          <p:cNvSpPr txBox="1"/>
+          <p:nvPr/>
+        </p:nvSpPr>
+        <p:spPr>
+          <a:xfrm>
+            <a:off x="685800" y="6400800"/>
+            <a:ext cx="3291840" cy="411480"/>
+          </a:xfrm>
+          <a:prstGeom prst="rect">
+            <a:avLst/>
+          </a:prstGeom>
+          <a:noFill/>
+        </p:spPr>
+        <p:txBody>
+          <a:bodyPr wrap="square">
+            <a:spAutoFit/>
+          </a:bodyPr>
+          <a:lstStyle/>
+          <a:p>
+            <a:pPr algn="l"/>
+            <a:r>
+              <a:rPr sz="1400" b="0">
+                <a:solidFill>
+                  <a:srgbClr val="444444"/>
+                </a:solidFill>
+              </a:rPr>
+              <a:t>Railway 部署＋除錯</a:t>
+            </a:r>
+          </a:p>
+        </p:txBody>
+      </p:sp>
+      <p:sp>
+        <p:nvSpPr>
+          <p:cNvPr id="30" name="TextBox 29"/>
+          <p:cNvSpPr txBox="1"/>
+          <p:nvPr/>
+        </p:nvSpPr>
+        <p:spPr>
+          <a:xfrm>
+            <a:off x="4023360" y="6400800"/>
+            <a:ext cx="1280160" cy="411480"/>
+          </a:xfrm>
+          <a:prstGeom prst="rect">
+            <a:avLst/>
+          </a:prstGeom>
+          <a:noFill/>
+        </p:spPr>
+        <p:txBody>
+          <a:bodyPr wrap="square">
+            <a:spAutoFit/>
+          </a:bodyPr>
+          <a:lstStyle/>
+          <a:p>
+            <a:pPr algn="r"/>
+            <a:r>
+              <a:rPr sz="1400" b="1">
+                <a:solidFill>
+                  <a:srgbClr val="E86A1A"/>
+                </a:solidFill>
+              </a:rPr>
+              <a:t>~1 hr</a:t>
+            </a:r>
+          </a:p>
+        </p:txBody>
+      </p:sp>
+      <p:sp>
+        <p:nvSpPr>
+          <p:cNvPr id="31" name="Rectangle 30"/>
+          <p:cNvSpPr/>
+          <p:nvPr/>
+        </p:nvSpPr>
+        <p:spPr>
+          <a:xfrm>
+            <a:off x="365760" y="6986016"/>
             <a:ext cx="5029200" cy="25400"/>
           </a:xfrm>
           <a:prstGeom prst="rect">
@@ -8098,13 +8644,13 @@
       </p:sp>
       <p:sp>
         <p:nvSpPr>
-          <p:cNvPr id="26" name="TextBox 25"/>
+          <p:cNvPr id="32" name="TextBox 31"/>
           <p:cNvSpPr txBox="1"/>
           <p:nvPr/>
         </p:nvSpPr>
         <p:spPr>
           <a:xfrm>
-            <a:off x="365760" y="5833872"/>
+            <a:off x="365760" y="7077456"/>
             <a:ext cx="5029200" cy="457200"/>
           </a:xfrm>
           <a:prstGeom prst="rect">
@@ -8125,14 +8671,14 @@
                   <a:srgbClr val="1A2E4A"/>
                 </a:solidFill>
               </a:rPr>
-              <a:t>總計：約 4 小時</a:t>
-            </a:r>
-          </a:p>
-        </p:txBody>
-      </p:sp>
-      <p:sp>
-        <p:nvSpPr>
-          <p:cNvPr id="27" name="TextBox 26"/>
+              <a:t>總計：約 6 小時</a:t>
+            </a:r>
+          </a:p>
+        </p:txBody>
+      </p:sp>
+      <p:sp>
+        <p:nvSpPr>
+          <p:cNvPr id="33" name="TextBox 32"/>
           <p:cNvSpPr txBox="1"/>
           <p:nvPr/>
         </p:nvSpPr>
@@ -8166,7 +8712,7 @@
       </p:sp>
       <p:sp>
         <p:nvSpPr>
-          <p:cNvPr id="28" name="Rectangle 27"/>
+          <p:cNvPr id="34" name="Rectangle 33"/>
           <p:cNvSpPr/>
           <p:nvPr/>
         </p:nvSpPr>
@@ -8211,7 +8757,7 @@
       </p:sp>
       <p:sp>
         <p:nvSpPr>
-          <p:cNvPr id="29" name="TextBox 28"/>
+          <p:cNvPr id="35" name="TextBox 34"/>
           <p:cNvSpPr txBox="1"/>
           <p:nvPr/>
         </p:nvSpPr>
@@ -8238,14 +8784,14 @@
                   <a:srgbClr val="27AE60"/>
                 </a:solidFill>
               </a:rPr>
-              <a:t>✓ RAG 向量搜尋（已實作）</a:t>
-            </a:r>
-          </a:p>
-        </p:txBody>
-      </p:sp>
-      <p:sp>
-        <p:nvSpPr>
-          <p:cNvPr id="30" name="TextBox 29"/>
+              <a:t>✓ RAG 向量搜尋（已完成）</a:t>
+            </a:r>
+          </a:p>
+        </p:txBody>
+      </p:sp>
+      <p:sp>
+        <p:nvSpPr>
+          <p:cNvPr id="36" name="TextBox 35"/>
           <p:cNvSpPr txBox="1"/>
           <p:nvPr/>
         </p:nvSpPr>
@@ -8272,20 +8818,246 @@
                   <a:srgbClr val="444444"/>
                 </a:solidFill>
               </a:rPr>
-              <a:t>只注入最相關段落，大幅減少 Token 用量，提升答題準確率</a:t>
-            </a:r>
-          </a:p>
-        </p:txBody>
-      </p:sp>
-      <p:sp>
-        <p:nvSpPr>
-          <p:cNvPr id="31" name="Rectangle 30"/>
+              <a:t>ChromaDB，603 chunks，TOP_K per source，只注入相關段落</a:t>
+            </a:r>
+          </a:p>
+        </p:txBody>
+      </p:sp>
+      <p:sp>
+        <p:nvSpPr>
+          <p:cNvPr id="37" name="Rectangle 36"/>
           <p:cNvSpPr/>
           <p:nvPr/>
         </p:nvSpPr>
         <p:spPr>
           <a:xfrm>
             <a:off x="6400800" y="2880360"/>
+            <a:ext cx="5394960" cy="777240"/>
+          </a:xfrm>
+          <a:prstGeom prst="rect">
+            <a:avLst/>
+          </a:prstGeom>
+          <a:solidFill>
+            <a:srgbClr val="E8F8ED"/>
+          </a:solidFill>
+          <a:ln w="12700">
+            <a:solidFill>
+              <a:srgbClr val="27AE60"/>
+            </a:solidFill>
+          </a:ln>
+        </p:spPr>
+        <p:style>
+          <a:lnRef idx="1">
+            <a:schemeClr val="accent1"/>
+          </a:lnRef>
+          <a:fillRef idx="3">
+            <a:schemeClr val="accent1"/>
+          </a:fillRef>
+          <a:effectRef idx="2">
+            <a:schemeClr val="accent1"/>
+          </a:effectRef>
+          <a:fontRef idx="minor">
+            <a:schemeClr val="lt1"/>
+          </a:fontRef>
+        </p:style>
+        <p:txBody>
+          <a:bodyPr rtlCol="0" anchor="ctr"/>
+          <a:lstStyle/>
+          <a:p>
+            <a:pPr algn="ctr"/>
+          </a:p>
+        </p:txBody>
+      </p:sp>
+      <p:sp>
+        <p:nvSpPr>
+          <p:cNvPr id="38" name="TextBox 37"/>
+          <p:cNvSpPr txBox="1"/>
+          <p:nvPr/>
+        </p:nvSpPr>
+        <p:spPr>
+          <a:xfrm>
+            <a:off x="6537960" y="2916936"/>
+            <a:ext cx="5120640" cy="329184"/>
+          </a:xfrm>
+          <a:prstGeom prst="rect">
+            <a:avLst/>
+          </a:prstGeom>
+          <a:noFill/>
+        </p:spPr>
+        <p:txBody>
+          <a:bodyPr wrap="square">
+            <a:spAutoFit/>
+          </a:bodyPr>
+          <a:lstStyle/>
+          <a:p>
+            <a:pPr algn="l"/>
+            <a:r>
+              <a:rPr sz="1400" b="1">
+                <a:solidFill>
+                  <a:srgbClr val="27AE60"/>
+                </a:solidFill>
+              </a:rPr>
+              <a:t>✓ Railway API 部署（已完成）</a:t>
+            </a:r>
+          </a:p>
+        </p:txBody>
+      </p:sp>
+      <p:sp>
+        <p:nvSpPr>
+          <p:cNvPr id="39" name="TextBox 38"/>
+          <p:cNvSpPr txBox="1"/>
+          <p:nvPr/>
+        </p:nvSpPr>
+        <p:spPr>
+          <a:xfrm>
+            <a:off x="6537960" y="3246120"/>
+            <a:ext cx="5120640" cy="365760"/>
+          </a:xfrm>
+          <a:prstGeom prst="rect">
+            <a:avLst/>
+          </a:prstGeom>
+          <a:noFill/>
+        </p:spPr>
+        <p:txBody>
+          <a:bodyPr wrap="square">
+            <a:spAutoFit/>
+          </a:bodyPr>
+          <a:lstStyle/>
+          <a:p>
+            <a:pPr algn="l"/>
+            <a:r>
+              <a:rPr sz="1200" b="0">
+                <a:solidFill>
+                  <a:srgbClr val="444444"/>
+                </a:solidFill>
+              </a:rPr>
+              <a:t>/ask + /health + /sources，向量搜尋啟用，fulltext fallback</a:t>
+            </a:r>
+          </a:p>
+        </p:txBody>
+      </p:sp>
+      <p:sp>
+        <p:nvSpPr>
+          <p:cNvPr id="40" name="Rectangle 39"/>
+          <p:cNvSpPr/>
+          <p:nvPr/>
+        </p:nvSpPr>
+        <p:spPr>
+          <a:xfrm>
+            <a:off x="6400800" y="3749040"/>
+            <a:ext cx="5394960" cy="777240"/>
+          </a:xfrm>
+          <a:prstGeom prst="rect">
+            <a:avLst/>
+          </a:prstGeom>
+          <a:solidFill>
+            <a:srgbClr val="FFF3E0"/>
+          </a:solidFill>
+          <a:ln w="12700">
+            <a:solidFill>
+              <a:srgbClr val="E86A1A"/>
+            </a:solidFill>
+          </a:ln>
+        </p:spPr>
+        <p:style>
+          <a:lnRef idx="1">
+            <a:schemeClr val="accent1"/>
+          </a:lnRef>
+          <a:fillRef idx="3">
+            <a:schemeClr val="accent1"/>
+          </a:fillRef>
+          <a:effectRef idx="2">
+            <a:schemeClr val="accent1"/>
+          </a:effectRef>
+          <a:fontRef idx="minor">
+            <a:schemeClr val="lt1"/>
+          </a:fontRef>
+        </p:style>
+        <p:txBody>
+          <a:bodyPr rtlCol="0" anchor="ctr"/>
+          <a:lstStyle/>
+          <a:p>
+            <a:pPr algn="ctr"/>
+          </a:p>
+        </p:txBody>
+      </p:sp>
+      <p:sp>
+        <p:nvSpPr>
+          <p:cNvPr id="41" name="TextBox 40"/>
+          <p:cNvSpPr txBox="1"/>
+          <p:nvPr/>
+        </p:nvSpPr>
+        <p:spPr>
+          <a:xfrm>
+            <a:off x="6537960" y="3785616"/>
+            <a:ext cx="5120640" cy="329184"/>
+          </a:xfrm>
+          <a:prstGeom prst="rect">
+            <a:avLst/>
+          </a:prstGeom>
+          <a:noFill/>
+        </p:spPr>
+        <p:txBody>
+          <a:bodyPr wrap="square">
+            <a:spAutoFit/>
+          </a:bodyPr>
+          <a:lstStyle/>
+          <a:p>
+            <a:pPr algn="l"/>
+            <a:r>
+              <a:rPr sz="1400" b="1">
+                <a:solidFill>
+                  <a:srgbClr val="E86A1A"/>
+                </a:solidFill>
+              </a:rPr>
+              <a:t>多語言 Embedding（進行中）</a:t>
+            </a:r>
+          </a:p>
+        </p:txBody>
+      </p:sp>
+      <p:sp>
+        <p:nvSpPr>
+          <p:cNvPr id="42" name="TextBox 41"/>
+          <p:cNvSpPr txBox="1"/>
+          <p:nvPr/>
+        </p:nvSpPr>
+        <p:spPr>
+          <a:xfrm>
+            <a:off x="6537960" y="4114800"/>
+            <a:ext cx="5120640" cy="365760"/>
+          </a:xfrm>
+          <a:prstGeom prst="rect">
+            <a:avLst/>
+          </a:prstGeom>
+          <a:noFill/>
+        </p:spPr>
+        <p:txBody>
+          <a:bodyPr wrap="square">
+            <a:spAutoFit/>
+          </a:bodyPr>
+          <a:lstStyle/>
+          <a:p>
+            <a:pPr algn="l"/>
+            <a:r>
+              <a:rPr sz="1200" b="0">
+                <a:solidFill>
+                  <a:srgbClr val="444444"/>
+                </a:solidFill>
+              </a:rPr>
+              <a:t>從英文 all-MiniLM 換成 multilingual-MiniLM-L12-v2，提升中文準確率</a:t>
+            </a:r>
+          </a:p>
+        </p:txBody>
+      </p:sp>
+      <p:sp>
+        <p:nvSpPr>
+          <p:cNvPr id="43" name="Rectangle 42"/>
+          <p:cNvSpPr/>
+          <p:nvPr/>
+        </p:nvSpPr>
+        <p:spPr>
+          <a:xfrm>
+            <a:off x="6400800" y="4617720"/>
             <a:ext cx="5394960" cy="777240"/>
           </a:xfrm>
           <a:prstGeom prst="rect">
@@ -8324,13 +9096,13 @@
       </p:sp>
       <p:sp>
         <p:nvSpPr>
-          <p:cNvPr id="32" name="TextBox 31"/>
+          <p:cNvPr id="44" name="TextBox 43"/>
           <p:cNvSpPr txBox="1"/>
           <p:nvPr/>
         </p:nvSpPr>
         <p:spPr>
           <a:xfrm>
-            <a:off x="6537960" y="2916936"/>
+            <a:off x="6537960" y="4654296"/>
             <a:ext cx="5120640" cy="329184"/>
           </a:xfrm>
           <a:prstGeom prst="rect">
@@ -8358,13 +9130,13 @@
       </p:sp>
       <p:sp>
         <p:nvSpPr>
-          <p:cNvPr id="33" name="TextBox 32"/>
+          <p:cNvPr id="45" name="TextBox 44"/>
           <p:cNvSpPr txBox="1"/>
           <p:nvPr/>
         </p:nvSpPr>
         <p:spPr>
           <a:xfrm>
-            <a:off x="6537960" y="3246120"/>
+            <a:off x="6537960" y="4983480"/>
             <a:ext cx="5120640" cy="365760"/>
           </a:xfrm>
           <a:prstGeom prst="rect">
@@ -8385,20 +9157,20 @@
                   <a:srgbClr val="444444"/>
                 </a:solidFill>
               </a:rPr>
-              <a:t>給 Hermes 工具（search_pdf / search_wav / search_xls / search_zip），由 Gemma 自行決定呼叫哪個</a:t>
-            </a:r>
-          </a:p>
-        </p:txBody>
-      </p:sp>
-      <p:sp>
-        <p:nvSpPr>
-          <p:cNvPr id="34" name="Rectangle 33"/>
+              <a:t>給 Gemma 工具（search_pdf/wav/xls/zip），自行決定呼叫哪個來源</a:t>
+            </a:r>
+          </a:p>
+        </p:txBody>
+      </p:sp>
+      <p:sp>
+        <p:nvSpPr>
+          <p:cNvPr id="46" name="Rectangle 45"/>
           <p:cNvSpPr/>
           <p:nvPr/>
         </p:nvSpPr>
         <p:spPr>
           <a:xfrm>
-            <a:off x="6400800" y="3749040"/>
+            <a:off x="6400800" y="5486400"/>
             <a:ext cx="5394960" cy="777240"/>
           </a:xfrm>
           <a:prstGeom prst="rect">
@@ -8437,13 +9209,13 @@
       </p:sp>
       <p:sp>
         <p:nvSpPr>
-          <p:cNvPr id="35" name="TextBox 34"/>
+          <p:cNvPr id="47" name="TextBox 46"/>
           <p:cNvSpPr txBox="1"/>
           <p:nvPr/>
         </p:nvSpPr>
         <p:spPr>
           <a:xfrm>
-            <a:off x="6537960" y="3785616"/>
+            <a:off x="6537960" y="5522976"/>
             <a:ext cx="5120640" cy="329184"/>
           </a:xfrm>
           <a:prstGeom prst="rect">
@@ -8471,13 +9243,13 @@
       </p:sp>
       <p:sp>
         <p:nvSpPr>
-          <p:cNvPr id="36" name="TextBox 35"/>
+          <p:cNvPr id="48" name="TextBox 47"/>
           <p:cNvSpPr txBox="1"/>
           <p:nvPr/>
         </p:nvSpPr>
         <p:spPr>
           <a:xfrm>
-            <a:off x="6537960" y="4114800"/>
+            <a:off x="6537960" y="5852160"/>
             <a:ext cx="5120640" cy="365760"/>
           </a:xfrm>
           <a:prstGeom prst="rect">
@@ -8498,240 +9270,14 @@
                   <a:srgbClr val="444444"/>
                 </a:solidFill>
               </a:rPr>
-              <a:t>同時引用 PDF 卷宗＋XLS 人口資料，回答需跨資料的複合問題</a:t>
-            </a:r>
-          </a:p>
-        </p:txBody>
-      </p:sp>
-      <p:sp>
-        <p:nvSpPr>
-          <p:cNvPr id="37" name="Rectangle 36"/>
-          <p:cNvSpPr/>
-          <p:nvPr/>
-        </p:nvSpPr>
-        <p:spPr>
-          <a:xfrm>
-            <a:off x="6400800" y="4617720"/>
-            <a:ext cx="5394960" cy="777240"/>
-          </a:xfrm>
-          <a:prstGeom prst="rect">
-            <a:avLst/>
-          </a:prstGeom>
-          <a:solidFill>
-            <a:srgbClr val="F4F6F8"/>
-          </a:solidFill>
-          <a:ln w="12700">
-            <a:solidFill>
-              <a:srgbClr val="008787"/>
-            </a:solidFill>
-          </a:ln>
-        </p:spPr>
-        <p:style>
-          <a:lnRef idx="1">
-            <a:schemeClr val="accent1"/>
-          </a:lnRef>
-          <a:fillRef idx="3">
-            <a:schemeClr val="accent1"/>
-          </a:fillRef>
-          <a:effectRef idx="2">
-            <a:schemeClr val="accent1"/>
-          </a:effectRef>
-          <a:fontRef idx="minor">
-            <a:schemeClr val="lt1"/>
-          </a:fontRef>
-        </p:style>
-        <p:txBody>
-          <a:bodyPr rtlCol="0" anchor="ctr"/>
-          <a:lstStyle/>
-          <a:p>
-            <a:pPr algn="ctr"/>
-          </a:p>
-        </p:txBody>
-      </p:sp>
-      <p:sp>
-        <p:nvSpPr>
-          <p:cNvPr id="38" name="TextBox 37"/>
-          <p:cNvSpPr txBox="1"/>
-          <p:nvPr/>
-        </p:nvSpPr>
-        <p:spPr>
-          <a:xfrm>
-            <a:off x="6537960" y="4654296"/>
-            <a:ext cx="5120640" cy="329184"/>
-          </a:xfrm>
-          <a:prstGeom prst="rect">
-            <a:avLst/>
-          </a:prstGeom>
-          <a:noFill/>
-        </p:spPr>
-        <p:txBody>
-          <a:bodyPr wrap="square">
-            <a:spAutoFit/>
-          </a:bodyPr>
-          <a:lstStyle/>
-          <a:p>
-            <a:pPr algn="l"/>
-            <a:r>
-              <a:rPr sz="1400" b="1">
-                <a:solidFill>
-                  <a:srgbClr val="008787"/>
-                </a:solidFill>
-              </a:rPr>
-              <a:t>非技術人員友善介面</a:t>
-            </a:r>
-          </a:p>
-        </p:txBody>
-      </p:sp>
-      <p:sp>
-        <p:nvSpPr>
-          <p:cNvPr id="39" name="TextBox 38"/>
-          <p:cNvSpPr txBox="1"/>
-          <p:nvPr/>
-        </p:nvSpPr>
-        <p:spPr>
-          <a:xfrm>
-            <a:off x="6537960" y="4983480"/>
-            <a:ext cx="5120640" cy="365760"/>
-          </a:xfrm>
-          <a:prstGeom prst="rect">
-            <a:avLst/>
-          </a:prstGeom>
-          <a:noFill/>
-        </p:spPr>
-        <p:txBody>
-          <a:bodyPr wrap="square">
-            <a:spAutoFit/>
-          </a:bodyPr>
-          <a:lstStyle/>
-          <a:p>
-            <a:pPr algn="l"/>
-            <a:r>
-              <a:rPr sz="1200" b="0">
-                <a:solidFill>
-                  <a:srgbClr val="444444"/>
-                </a:solidFill>
-              </a:rPr>
-              <a:t>包一個簡單 Web UI：輸入問題 → 輸出引用答案，隱藏 API 細節</a:t>
-            </a:r>
-          </a:p>
-        </p:txBody>
-      </p:sp>
-      <p:sp>
-        <p:nvSpPr>
-          <p:cNvPr id="40" name="Rectangle 39"/>
-          <p:cNvSpPr/>
-          <p:nvPr/>
-        </p:nvSpPr>
-        <p:spPr>
-          <a:xfrm>
-            <a:off x="6400800" y="5486400"/>
-            <a:ext cx="5394960" cy="777240"/>
-          </a:xfrm>
-          <a:prstGeom prst="rect">
-            <a:avLst/>
-          </a:prstGeom>
-          <a:solidFill>
-            <a:srgbClr val="F4F6F8"/>
-          </a:solidFill>
-          <a:ln w="12700">
-            <a:solidFill>
-              <a:srgbClr val="008787"/>
-            </a:solidFill>
-          </a:ln>
-        </p:spPr>
-        <p:style>
-          <a:lnRef idx="1">
-            <a:schemeClr val="accent1"/>
-          </a:lnRef>
-          <a:fillRef idx="3">
-            <a:schemeClr val="accent1"/>
-          </a:fillRef>
-          <a:effectRef idx="2">
-            <a:schemeClr val="accent1"/>
-          </a:effectRef>
-          <a:fontRef idx="minor">
-            <a:schemeClr val="lt1"/>
-          </a:fontRef>
-        </p:style>
-        <p:txBody>
-          <a:bodyPr rtlCol="0" anchor="ctr"/>
-          <a:lstStyle/>
-          <a:p>
-            <a:pPr algn="ctr"/>
-          </a:p>
-        </p:txBody>
-      </p:sp>
-      <p:sp>
-        <p:nvSpPr>
-          <p:cNvPr id="41" name="TextBox 40"/>
-          <p:cNvSpPr txBox="1"/>
-          <p:nvPr/>
-        </p:nvSpPr>
-        <p:spPr>
-          <a:xfrm>
-            <a:off x="6537960" y="5522976"/>
-            <a:ext cx="5120640" cy="329184"/>
-          </a:xfrm>
-          <a:prstGeom prst="rect">
-            <a:avLst/>
-          </a:prstGeom>
-          <a:noFill/>
-        </p:spPr>
-        <p:txBody>
-          <a:bodyPr wrap="square">
-            <a:spAutoFit/>
-          </a:bodyPr>
-          <a:lstStyle/>
-          <a:p>
-            <a:pPr algn="l"/>
-            <a:r>
-              <a:rPr sz="1400" b="1">
-                <a:solidFill>
-                  <a:srgbClr val="008787"/>
-                </a:solidFill>
-              </a:rPr>
-              <a:t>技能包版本管理</a:t>
-            </a:r>
-          </a:p>
-        </p:txBody>
-      </p:sp>
-      <p:sp>
-        <p:nvSpPr>
-          <p:cNvPr id="42" name="TextBox 41"/>
-          <p:cNvSpPr txBox="1"/>
-          <p:nvPr/>
-        </p:nvSpPr>
-        <p:spPr>
-          <a:xfrm>
-            <a:off x="6537960" y="5852160"/>
-            <a:ext cx="5120640" cy="365760"/>
-          </a:xfrm>
-          <a:prstGeom prst="rect">
-            <a:avLst/>
-          </a:prstGeom>
-          <a:noFill/>
-        </p:spPr>
-        <p:txBody>
-          <a:bodyPr wrap="square">
-            <a:spAutoFit/>
-          </a:bodyPr>
-          <a:lstStyle/>
-          <a:p>
-            <a:pPr algn="l"/>
-            <a:r>
-              <a:rPr sz="1200" b="0">
-                <a:solidFill>
-                  <a:srgbClr val="444444"/>
-                </a:solidFill>
-              </a:rPr>
-              <a:t>資料更新時自動重新前處理，確保 references 與向量索引永遠最新</a:t>
-            </a:r>
-          </a:p>
-        </p:txBody>
-      </p:sp>
-      <p:sp>
-        <p:nvSpPr>
-          <p:cNvPr id="43" name="Rectangle 42"/>
+              <a:t>同時引用 PDF 卷宗＋XLS 人口資料，回答跨來源的複合問題</a:t>
+            </a:r>
+          </a:p>
+        </p:txBody>
+      </p:sp>
+      <p:sp>
+        <p:nvSpPr>
+          <p:cNvPr id="49" name="Rectangle 48"/>
           <p:cNvSpPr/>
           <p:nvPr/>
         </p:nvSpPr>
@@ -8774,7 +9320,7 @@
       </p:sp>
       <p:sp>
         <p:nvSpPr>
-          <p:cNvPr id="44" name="TextBox 43"/>
+          <p:cNvPr id="50" name="TextBox 49"/>
           <p:cNvSpPr txBox="1"/>
           <p:nvPr/>
         </p:nvSpPr>

</xml_diff>